<commit_message>
feat: set official team credentials: Team MEGHDOOT (ID: SIH26068)
</commit_message>
<xml_diff>
--- a/WeatherGPT_SIH2026_Official_Submission.pptx
+++ b/WeatherGPT_SIH2026_Official_Submission.pptx
@@ -1978,7 +1978,7 @@
                 <a:ea typeface="Arial" pitchFamily="34" charset="-122"/>
                 <a:cs typeface="Arial" pitchFamily="34" charset="-120"/>
               </a:rPr>
-              <a:t>[Team ID / Registered ID]</a:t>
+              <a:t>SIH26068</a:t>
             </a:r>
             <a:endParaRPr lang="en-US" sz="1150" dirty="0"/>
           </a:p>
@@ -2059,7 +2059,7 @@
                 <a:ea typeface="Arial" pitchFamily="34" charset="-122"/>
                 <a:cs typeface="Arial" pitchFamily="34" charset="-120"/>
               </a:rPr>
-              <a:t>Team WeatherGPT</a:t>
+              <a:t>MEGHDOOT</a:t>
             </a:r>
             <a:endParaRPr lang="en-US" sz="1150" dirty="0"/>
           </a:p>
@@ -2369,7 +2369,7 @@
                 <a:ea typeface="Arial" pitchFamily="34" charset="-122"/>
                 <a:cs typeface="Arial" pitchFamily="34" charset="-120"/>
               </a:rPr>
-              <a:t>Team WeatherGPT</a:t>
+              <a:t>MEGHDOOT</a:t>
             </a:r>
             <a:endParaRPr lang="en-US" sz="950" dirty="0"/>
           </a:p>
@@ -3089,7 +3089,7 @@
                 <a:ea typeface="Arial" pitchFamily="34" charset="-122"/>
                 <a:cs typeface="Arial" pitchFamily="34" charset="-120"/>
               </a:rPr>
-              <a:t>Team WeatherGPT</a:t>
+              <a:t>MEGHDOOT</a:t>
             </a:r>
             <a:endParaRPr lang="en-US" sz="950" dirty="0"/>
           </a:p>
@@ -4594,7 +4594,7 @@
                 <a:ea typeface="Arial" pitchFamily="34" charset="-122"/>
                 <a:cs typeface="Arial" pitchFamily="34" charset="-120"/>
               </a:rPr>
-              <a:t>Team WeatherGPT</a:t>
+              <a:t>MEGHDOOT</a:t>
             </a:r>
             <a:endParaRPr lang="en-US" sz="950" dirty="0"/>
           </a:p>
@@ -6137,7 +6137,7 @@
                 <a:ea typeface="Arial" pitchFamily="34" charset="-122"/>
                 <a:cs typeface="Arial" pitchFamily="34" charset="-120"/>
               </a:rPr>
-              <a:t>Team WeatherGPT</a:t>
+              <a:t>MEGHDOOT</a:t>
             </a:r>
             <a:endParaRPr lang="en-US" sz="950" dirty="0"/>
           </a:p>
@@ -7429,7 +7429,7 @@
                 <a:ea typeface="Arial" pitchFamily="34" charset="-122"/>
                 <a:cs typeface="Arial" pitchFamily="34" charset="-120"/>
               </a:rPr>
-              <a:t>Team WeatherGPT</a:t>
+              <a:t>MEGHDOOT</a:t>
             </a:r>
             <a:endParaRPr lang="en-US" sz="950" dirty="0"/>
           </a:p>

</xml_diff>